<commit_message>
White diamond, gold JEWELRY per client feedback
</commit_message>
<xml_diff>
--- a/deck/Zisel_Market_Snapshot.pptx
+++ b/deck/Zisel_Market_Snapshot.pptx
@@ -4,9 +4,6 @@
   <p:sldMasterIdLst>
     <p:sldMasterId id="2147483648" r:id="rId1"/>
   </p:sldMasterIdLst>
-  <p:notesMasterIdLst>
-    <p:notesMasterId r:id="rId15"/>
-  </p:notesMasterIdLst>
   <p:sldIdLst>
     <p:sldId id="256" r:id="rId2"/>
     <p:sldId id="257" r:id="rId3"/>
@@ -22,6 +19,9 @@
     <p:sldId id="267" r:id="rId13"/>
     <p:sldId id="268" r:id="rId14"/>
   </p:sldIdLst>
+  <p:notesMasterIdLst>
+    <p:notesMasterId r:id="rId15"/>
+  </p:notesMasterIdLst>
   <p:sldSz cx="12192000" cy="6858000"/>
   <p:notesSz cx="6858000" cy="12192000"/>
   <p:defaultTextStyle>
@@ -2238,6 +2238,9 @@
               </a:rPr>
               <a:t>Zisel</a:t>
             </a:r>
+            <a:pPr indent="0" marL="0">
+              <a:buNone/>
+            </a:pPr>
             <a:r>
               <a:rPr lang="en-US" sz="1000" dirty="0">
                 <a:solidFill>
@@ -3170,6 +3173,9 @@
               </a:rPr>
               <a:t>Zisel</a:t>
             </a:r>
+            <a:pPr indent="0" marL="0">
+              <a:buNone/>
+            </a:pPr>
             <a:r>
               <a:rPr lang="en-US" sz="1000" dirty="0">
                 <a:solidFill>
@@ -3954,11 +3960,11 @@
             <a:avLst/>
           </a:prstGeom>
           <a:solidFill>
-            <a:srgbClr val="C6A15B"/>
+            <a:srgbClr val="FFFFFF"/>
           </a:solidFill>
-          <a:ln w="12700">
+          <a:ln w="9525">
             <a:solidFill>
-              <a:srgbClr val="C6A15B"/>
+              <a:srgbClr val="6F7F99"/>
             </a:solidFill>
             <a:prstDash val="solid"/>
           </a:ln>
@@ -4018,11 +4024,11 @@
             <a:avLst/>
           </a:prstGeom>
           <a:solidFill>
-            <a:srgbClr val="C6A15B"/>
+            <a:srgbClr val="FFFFFF"/>
           </a:solidFill>
-          <a:ln w="12700">
+          <a:ln w="9525">
             <a:solidFill>
-              <a:srgbClr val="C6A15B"/>
+              <a:srgbClr val="6F7F99"/>
             </a:solidFill>
             <a:prstDash val="solid"/>
           </a:ln>
@@ -4082,11 +4088,11 @@
             <a:avLst/>
           </a:prstGeom>
           <a:solidFill>
-            <a:srgbClr val="C6A15B"/>
+            <a:srgbClr val="FFFFFF"/>
           </a:solidFill>
-          <a:ln w="12700">
+          <a:ln w="9525">
             <a:solidFill>
-              <a:srgbClr val="C6A15B"/>
+              <a:srgbClr val="6F7F99"/>
             </a:solidFill>
             <a:prstDash val="solid"/>
           </a:ln>
@@ -4146,11 +4152,11 @@
             <a:avLst/>
           </a:prstGeom>
           <a:solidFill>
-            <a:srgbClr val="C6A15B"/>
+            <a:srgbClr val="FFFFFF"/>
           </a:solidFill>
-          <a:ln w="12700">
+          <a:ln w="9525">
             <a:solidFill>
-              <a:srgbClr val="C6A15B"/>
+              <a:srgbClr val="6F7F99"/>
             </a:solidFill>
             <a:prstDash val="solid"/>
           </a:ln>
@@ -4255,6 +4261,9 @@
               </a:rPr>
               <a:t>Hanukkah</a:t>
             </a:r>
+            <a:pPr indent="0" marL="0">
+              <a:buNone/>
+            </a:pPr>
             <a:r>
               <a:rPr lang="en-US" sz="1150" dirty="0">
                 <a:solidFill>
@@ -4285,11 +4294,11 @@
             <a:avLst/>
           </a:prstGeom>
           <a:solidFill>
-            <a:srgbClr val="C6A15B"/>
+            <a:srgbClr val="FFFFFF"/>
           </a:solidFill>
-          <a:ln w="12700">
+          <a:ln w="9525">
             <a:solidFill>
-              <a:srgbClr val="C6A15B"/>
+              <a:srgbClr val="6F7F99"/>
             </a:solidFill>
             <a:prstDash val="solid"/>
           </a:ln>
@@ -4330,6 +4339,9 @@
               </a:rPr>
               <a:t>Order custom by  </a:t>
             </a:r>
+            <a:pPr indent="0" marL="0">
+              <a:buNone/>
+            </a:pPr>
             <a:r>
               <a:rPr lang="en-US" sz="1700" b="1" dirty="0">
                 <a:solidFill>
@@ -4444,6 +4456,9 @@
               </a:rPr>
               <a:t>Christmas</a:t>
             </a:r>
+            <a:pPr indent="0" marL="0">
+              <a:buNone/>
+            </a:pPr>
             <a:r>
               <a:rPr lang="en-US" sz="1150" dirty="0">
                 <a:solidFill>
@@ -4474,11 +4489,11 @@
             <a:avLst/>
           </a:prstGeom>
           <a:solidFill>
-            <a:srgbClr val="C6A15B"/>
+            <a:srgbClr val="FFFFFF"/>
           </a:solidFill>
-          <a:ln w="12700">
+          <a:ln w="9525">
             <a:solidFill>
-              <a:srgbClr val="C6A15B"/>
+              <a:srgbClr val="6F7F99"/>
             </a:solidFill>
             <a:prstDash val="solid"/>
           </a:ln>
@@ -4519,6 +4534,9 @@
               </a:rPr>
               <a:t>Order custom by  </a:t>
             </a:r>
+            <a:pPr indent="0" marL="0">
+              <a:buNone/>
+            </a:pPr>
             <a:r>
               <a:rPr lang="en-US" sz="1700" b="1" dirty="0">
                 <a:solidFill>
@@ -4633,6 +4651,9 @@
               </a:rPr>
               <a:t>Valentine’s Day</a:t>
             </a:r>
+            <a:pPr indent="0" marL="0">
+              <a:buNone/>
+            </a:pPr>
             <a:r>
               <a:rPr lang="en-US" sz="1150" dirty="0">
                 <a:solidFill>
@@ -4663,11 +4684,11 @@
             <a:avLst/>
           </a:prstGeom>
           <a:solidFill>
-            <a:srgbClr val="C6A15B"/>
+            <a:srgbClr val="FFFFFF"/>
           </a:solidFill>
-          <a:ln w="12700">
+          <a:ln w="9525">
             <a:solidFill>
-              <a:srgbClr val="C6A15B"/>
+              <a:srgbClr val="6F7F99"/>
             </a:solidFill>
             <a:prstDash val="solid"/>
           </a:ln>
@@ -4708,6 +4729,9 @@
               </a:rPr>
               <a:t>Order custom by  </a:t>
             </a:r>
+            <a:pPr indent="0" marL="0">
+              <a:buNone/>
+            </a:pPr>
             <a:r>
               <a:rPr lang="en-US" sz="1700" b="1" dirty="0">
                 <a:solidFill>
@@ -4868,6 +4892,9 @@
               </a:rPr>
               <a:t>Zisel</a:t>
             </a:r>
+            <a:pPr indent="0" marL="0">
+              <a:buNone/>
+            </a:pPr>
             <a:r>
               <a:rPr lang="en-US" sz="1000" dirty="0">
                 <a:solidFill>
@@ -6013,6 +6040,9 @@
               </a:rPr>
               <a:t>Most urgent:  </a:t>
             </a:r>
+            <a:pPr indent="0" marL="0">
+              <a:buNone/>
+            </a:pPr>
             <a:r>
               <a:rPr lang="en-US" sz="1400" dirty="0">
                 <a:solidFill>
@@ -6095,6 +6125,9 @@
               </a:rPr>
               <a:t>Zisel</a:t>
             </a:r>
+            <a:pPr indent="0" marL="0">
+              <a:buNone/>
+            </a:pPr>
             <a:r>
               <a:rPr lang="en-US" sz="1000" dirty="0">
                 <a:solidFill>
@@ -7355,6 +7388,9 @@
               </a:rPr>
               <a:t>Zisel</a:t>
             </a:r>
+            <a:pPr indent="0" marL="0">
+              <a:buNone/>
+            </a:pPr>
             <a:r>
               <a:rPr lang="en-US" sz="1000" dirty="0">
                 <a:solidFill>
@@ -7997,6 +8033,9 @@
               </a:rPr>
               <a:t>Zisel</a:t>
             </a:r>
+            <a:pPr indent="0" marL="0">
+              <a:buNone/>
+            </a:pPr>
             <a:r>
               <a:rPr lang="en-US" sz="1000" dirty="0">
                 <a:solidFill>
@@ -8989,6 +9028,9 @@
               </a:rPr>
               <a:t>Recommendation:  </a:t>
             </a:r>
+            <a:pPr indent="0" marL="0">
+              <a:buNone/>
+            </a:pPr>
             <a:r>
               <a:rPr lang="en-US" sz="1500" dirty="0">
                 <a:solidFill>
@@ -9071,6 +9113,9 @@
               </a:rPr>
               <a:t>Zisel</a:t>
             </a:r>
+            <a:pPr indent="0" marL="0">
+              <a:buNone/>
+            </a:pPr>
             <a:r>
               <a:rPr lang="en-US" sz="1000" dirty="0">
                 <a:solidFill>
@@ -9189,7 +9234,7 @@
       </p:sp>
       <p:graphicFrame>
         <p:nvGraphicFramePr>
-          <p:cNvPr id="9" name="Table 0"/>
+          <p:cNvPr id="5" name="Table 0"/>
           <p:cNvGraphicFramePr>
             <a:graphicFrameLocks noGrp="1"/>
           </p:cNvGraphicFramePr>
@@ -10489,6 +10534,9 @@
               </a:rPr>
               <a:t>What it means:  </a:t>
             </a:r>
+            <a:pPr indent="0" marL="0">
+              <a:buNone/>
+            </a:pPr>
             <a:r>
               <a:rPr lang="en-US" sz="1500" dirty="0">
                 <a:solidFill>
@@ -10610,6 +10658,9 @@
               </a:rPr>
               <a:t>Zisel</a:t>
             </a:r>
+            <a:pPr indent="0" marL="0">
+              <a:buNone/>
+            </a:pPr>
             <a:r>
               <a:rPr lang="en-US" sz="1000" dirty="0">
                 <a:solidFill>
@@ -10766,11 +10817,11 @@
             <a:avLst/>
           </a:prstGeom>
           <a:solidFill>
-            <a:srgbClr val="C6A15B"/>
+            <a:srgbClr val="FFFFFF"/>
           </a:solidFill>
-          <a:ln w="12700">
+          <a:ln w="15875">
             <a:solidFill>
-              <a:srgbClr val="C6A15B"/>
+              <a:srgbClr val="6F7F99"/>
             </a:solidFill>
             <a:prstDash val="solid"/>
           </a:ln>
@@ -10995,11 +11046,11 @@
             <a:avLst/>
           </a:prstGeom>
           <a:solidFill>
-            <a:srgbClr val="C6A15B"/>
+            <a:srgbClr val="FFFFFF"/>
           </a:solidFill>
-          <a:ln w="12700">
+          <a:ln w="15875">
             <a:solidFill>
-              <a:srgbClr val="C6A15B"/>
+              <a:srgbClr val="6F7F99"/>
             </a:solidFill>
             <a:prstDash val="solid"/>
           </a:ln>
@@ -11219,6 +11270,9 @@
               </a:rPr>
               <a:t>Recommendation:  </a:t>
             </a:r>
+            <a:pPr indent="0" marL="0">
+              <a:buNone/>
+            </a:pPr>
             <a:r>
               <a:rPr lang="en-US" sz="1600" dirty="0">
                 <a:solidFill>
@@ -11340,6 +11394,9 @@
               </a:rPr>
               <a:t>Zisel</a:t>
             </a:r>
+            <a:pPr indent="0" marL="0">
+              <a:buNone/>
+            </a:pPr>
             <a:r>
               <a:rPr lang="en-US" sz="1000" dirty="0">
                 <a:solidFill>
@@ -12931,7 +12988,7 @@
       </p:graphicFrame>
       <p:sp>
         <p:nvSpPr>
-          <p:cNvPr id="13" name="Shape 4"/>
+          <p:cNvPr id="7" name="Shape 4"/>
           <p:cNvSpPr/>
           <p:nvPr/>
         </p:nvSpPr>
@@ -13200,6 +13257,9 @@
               </a:rPr>
               <a:t>Zisel</a:t>
             </a:r>
+            <a:pPr indent="0" marL="0">
+              <a:buNone/>
+            </a:pPr>
             <a:r>
               <a:rPr lang="en-US" sz="1000" dirty="0">
                 <a:solidFill>
@@ -13367,6 +13427,616 @@
             <a:ext cx="237744" cy="237744"/>
           </a:xfrm>
           <a:prstGeom prst="diamond">
+            <a:avLst/>
+          </a:prstGeom>
+          <a:solidFill>
+            <a:srgbClr val="FFFFFF"/>
+          </a:solidFill>
+          <a:ln w="9525">
+            <a:solidFill>
+              <a:srgbClr val="6F7F99"/>
+            </a:solidFill>
+            <a:prstDash val="solid"/>
+          </a:ln>
+        </p:spPr>
+      </p:sp>
+      <p:sp>
+        <p:nvSpPr>
+          <p:cNvPr id="8" name="Text 6"/>
+          <p:cNvSpPr/>
+          <p:nvPr/>
+        </p:nvSpPr>
+        <p:spPr>
+          <a:xfrm>
+            <a:off x="960120" y="2103120"/>
+            <a:ext cx="5394960" cy="384048"/>
+          </a:xfrm>
+          <a:prstGeom prst="rect">
+            <a:avLst/>
+          </a:prstGeom>
+          <a:noFill/>
+          <a:ln/>
+        </p:spPr>
+        <p:txBody>
+          <a:bodyPr wrap="square" lIns="0" tIns="0" rIns="0" bIns="0" rtlCol="0" anchor="ctr"/>
+          <a:lstStyle/>
+          <a:p>
+            <a:pPr indent="0" marL="0">
+              <a:buNone/>
+            </a:pPr>
+            <a:r>
+              <a:rPr lang="en-US" sz="1450" b="1" dirty="0">
+                <a:solidFill>
+                  <a:srgbClr val="0F2142"/>
+                </a:solidFill>
+                <a:latin typeface="Montserrat" pitchFamily="34" charset="0"/>
+                <a:ea typeface="Montserrat" pitchFamily="34" charset="-122"/>
+                <a:cs typeface="Montserrat" pitchFamily="34" charset="-120"/>
+              </a:rPr>
+              <a:t>Tennis bracelets</a:t>
+            </a:r>
+            <a:pPr indent="0" marL="0">
+              <a:buNone/>
+            </a:pPr>
+            <a:r>
+              <a:rPr lang="en-US" sz="1450" dirty="0">
+                <a:solidFill>
+                  <a:srgbClr val="5B6478"/>
+                </a:solidFill>
+                <a:latin typeface="Montserrat" pitchFamily="34" charset="0"/>
+                <a:ea typeface="Montserrat" pitchFamily="34" charset="-122"/>
+                <a:cs typeface="Montserrat" pitchFamily="34" charset="-120"/>
+              </a:rPr>
+              <a:t>   the #1 holiday gift</a:t>
+            </a:r>
+            <a:endParaRPr lang="en-US" sz="1450" dirty="0"/>
+          </a:p>
+        </p:txBody>
+      </p:sp>
+      <p:sp>
+        <p:nvSpPr>
+          <p:cNvPr id="9" name="Shape 7"/>
+          <p:cNvSpPr/>
+          <p:nvPr/>
+        </p:nvSpPr>
+        <p:spPr>
+          <a:xfrm>
+            <a:off x="548640" y="2779776"/>
+            <a:ext cx="237744" cy="237744"/>
+          </a:xfrm>
+          <a:prstGeom prst="diamond">
+            <a:avLst/>
+          </a:prstGeom>
+          <a:solidFill>
+            <a:srgbClr val="FFFFFF"/>
+          </a:solidFill>
+          <a:ln w="9525">
+            <a:solidFill>
+              <a:srgbClr val="6F7F99"/>
+            </a:solidFill>
+            <a:prstDash val="solid"/>
+          </a:ln>
+        </p:spPr>
+      </p:sp>
+      <p:sp>
+        <p:nvSpPr>
+          <p:cNvPr id="10" name="Text 8"/>
+          <p:cNvSpPr/>
+          <p:nvPr/>
+        </p:nvSpPr>
+        <p:spPr>
+          <a:xfrm>
+            <a:off x="960120" y="2706624"/>
+            <a:ext cx="5394960" cy="384048"/>
+          </a:xfrm>
+          <a:prstGeom prst="rect">
+            <a:avLst/>
+          </a:prstGeom>
+          <a:noFill/>
+          <a:ln/>
+        </p:spPr>
+        <p:txBody>
+          <a:bodyPr wrap="square" lIns="0" tIns="0" rIns="0" bIns="0" rtlCol="0" anchor="ctr"/>
+          <a:lstStyle/>
+          <a:p>
+            <a:pPr indent="0" marL="0">
+              <a:buNone/>
+            </a:pPr>
+            <a:r>
+              <a:rPr lang="en-US" sz="1450" b="1" dirty="0">
+                <a:solidFill>
+                  <a:srgbClr val="0F2142"/>
+                </a:solidFill>
+                <a:latin typeface="Montserrat" pitchFamily="34" charset="0"/>
+                <a:ea typeface="Montserrat" pitchFamily="34" charset="-122"/>
+                <a:cs typeface="Montserrat" pitchFamily="34" charset="-120"/>
+              </a:rPr>
+              <a:t>Diamond studs</a:t>
+            </a:r>
+            <a:pPr indent="0" marL="0">
+              <a:buNone/>
+            </a:pPr>
+            <a:r>
+              <a:rPr lang="en-US" sz="1450" dirty="0">
+                <a:solidFill>
+                  <a:srgbClr val="5B6478"/>
+                </a:solidFill>
+                <a:latin typeface="Montserrat" pitchFamily="34" charset="0"/>
+                <a:ea typeface="Montserrat" pitchFamily="34" charset="-122"/>
+                <a:cs typeface="Montserrat" pitchFamily="34" charset="-120"/>
+              </a:rPr>
+              <a:t>   the classic first fine-jewelry gift</a:t>
+            </a:r>
+            <a:endParaRPr lang="en-US" sz="1450" dirty="0"/>
+          </a:p>
+        </p:txBody>
+      </p:sp>
+      <p:sp>
+        <p:nvSpPr>
+          <p:cNvPr id="11" name="Shape 9"/>
+          <p:cNvSpPr/>
+          <p:nvPr/>
+        </p:nvSpPr>
+        <p:spPr>
+          <a:xfrm>
+            <a:off x="548640" y="3383280"/>
+            <a:ext cx="237744" cy="237744"/>
+          </a:xfrm>
+          <a:prstGeom prst="diamond">
+            <a:avLst/>
+          </a:prstGeom>
+          <a:solidFill>
+            <a:srgbClr val="FFFFFF"/>
+          </a:solidFill>
+          <a:ln w="9525">
+            <a:solidFill>
+              <a:srgbClr val="6F7F99"/>
+            </a:solidFill>
+            <a:prstDash val="solid"/>
+          </a:ln>
+        </p:spPr>
+      </p:sp>
+      <p:sp>
+        <p:nvSpPr>
+          <p:cNvPr id="12" name="Text 10"/>
+          <p:cNvSpPr/>
+          <p:nvPr/>
+        </p:nvSpPr>
+        <p:spPr>
+          <a:xfrm>
+            <a:off x="960120" y="3310128"/>
+            <a:ext cx="5394960" cy="384048"/>
+          </a:xfrm>
+          <a:prstGeom prst="rect">
+            <a:avLst/>
+          </a:prstGeom>
+          <a:noFill/>
+          <a:ln/>
+        </p:spPr>
+        <p:txBody>
+          <a:bodyPr wrap="square" lIns="0" tIns="0" rIns="0" bIns="0" rtlCol="0" anchor="ctr"/>
+          <a:lstStyle/>
+          <a:p>
+            <a:pPr indent="0" marL="0">
+              <a:buNone/>
+            </a:pPr>
+            <a:r>
+              <a:rPr lang="en-US" sz="1450" b="1" dirty="0">
+                <a:solidFill>
+                  <a:srgbClr val="0F2142"/>
+                </a:solidFill>
+                <a:latin typeface="Montserrat" pitchFamily="34" charset="0"/>
+                <a:ea typeface="Montserrat" pitchFamily="34" charset="-122"/>
+                <a:cs typeface="Montserrat" pitchFamily="34" charset="-120"/>
+              </a:rPr>
+              <a:t>Tennis necklaces</a:t>
+            </a:r>
+            <a:pPr indent="0" marL="0">
+              <a:buNone/>
+            </a:pPr>
+            <a:r>
+              <a:rPr lang="en-US" sz="1450" dirty="0">
+                <a:solidFill>
+                  <a:srgbClr val="5B6478"/>
+                </a:solidFill>
+                <a:latin typeface="Montserrat" pitchFamily="34" charset="0"/>
+                <a:ea typeface="Montserrat" pitchFamily="34" charset="-122"/>
+                <a:cs typeface="Montserrat" pitchFamily="34" charset="-120"/>
+              </a:rPr>
+              <a:t>   right behind bracelets</a:t>
+            </a:r>
+            <a:endParaRPr lang="en-US" sz="1450" dirty="0"/>
+          </a:p>
+        </p:txBody>
+      </p:sp>
+      <p:sp>
+        <p:nvSpPr>
+          <p:cNvPr id="13" name="Shape 11"/>
+          <p:cNvSpPr/>
+          <p:nvPr/>
+        </p:nvSpPr>
+        <p:spPr>
+          <a:xfrm>
+            <a:off x="548640" y="3986784"/>
+            <a:ext cx="237744" cy="237744"/>
+          </a:xfrm>
+          <a:prstGeom prst="diamond">
+            <a:avLst/>
+          </a:prstGeom>
+          <a:solidFill>
+            <a:srgbClr val="FFFFFF"/>
+          </a:solidFill>
+          <a:ln w="9525">
+            <a:solidFill>
+              <a:srgbClr val="6F7F99"/>
+            </a:solidFill>
+            <a:prstDash val="solid"/>
+          </a:ln>
+        </p:spPr>
+      </p:sp>
+      <p:sp>
+        <p:nvSpPr>
+          <p:cNvPr id="14" name="Text 12"/>
+          <p:cNvSpPr/>
+          <p:nvPr/>
+        </p:nvSpPr>
+        <p:spPr>
+          <a:xfrm>
+            <a:off x="960120" y="3913632"/>
+            <a:ext cx="5394960" cy="384048"/>
+          </a:xfrm>
+          <a:prstGeom prst="rect">
+            <a:avLst/>
+          </a:prstGeom>
+          <a:noFill/>
+          <a:ln/>
+        </p:spPr>
+        <p:txBody>
+          <a:bodyPr wrap="square" lIns="0" tIns="0" rIns="0" bIns="0" rtlCol="0" anchor="ctr"/>
+          <a:lstStyle/>
+          <a:p>
+            <a:pPr indent="0" marL="0">
+              <a:buNone/>
+            </a:pPr>
+            <a:r>
+              <a:rPr lang="en-US" sz="1450" b="1" dirty="0">
+                <a:solidFill>
+                  <a:srgbClr val="0F2142"/>
+                </a:solidFill>
+                <a:latin typeface="Montserrat" pitchFamily="34" charset="0"/>
+                <a:ea typeface="Montserrat" pitchFamily="34" charset="-122"/>
+                <a:cs typeface="Montserrat" pitchFamily="34" charset="-120"/>
+              </a:rPr>
+              <a:t>Gold chains</a:t>
+            </a:r>
+            <a:pPr indent="0" marL="0">
+              <a:buNone/>
+            </a:pPr>
+            <a:r>
+              <a:rPr lang="en-US" sz="1450" dirty="0">
+                <a:solidFill>
+                  <a:srgbClr val="5B6478"/>
+                </a:solidFill>
+                <a:latin typeface="Montserrat" pitchFamily="34" charset="0"/>
+                <a:ea typeface="Montserrat" pitchFamily="34" charset="-122"/>
+                <a:cs typeface="Montserrat" pitchFamily="34" charset="-120"/>
+              </a:rPr>
+              <a:t>   Cuban (the Vegas favorite), rope, paperclip</a:t>
+            </a:r>
+            <a:endParaRPr lang="en-US" sz="1450" dirty="0"/>
+          </a:p>
+        </p:txBody>
+      </p:sp>
+      <p:sp>
+        <p:nvSpPr>
+          <p:cNvPr id="15" name="Shape 13"/>
+          <p:cNvSpPr/>
+          <p:nvPr/>
+        </p:nvSpPr>
+        <p:spPr>
+          <a:xfrm>
+            <a:off x="548640" y="4590288"/>
+            <a:ext cx="237744" cy="237744"/>
+          </a:xfrm>
+          <a:prstGeom prst="diamond">
+            <a:avLst/>
+          </a:prstGeom>
+          <a:solidFill>
+            <a:srgbClr val="FFFFFF"/>
+          </a:solidFill>
+          <a:ln w="9525">
+            <a:solidFill>
+              <a:srgbClr val="6F7F99"/>
+            </a:solidFill>
+            <a:prstDash val="solid"/>
+          </a:ln>
+        </p:spPr>
+      </p:sp>
+      <p:sp>
+        <p:nvSpPr>
+          <p:cNvPr id="16" name="Text 14"/>
+          <p:cNvSpPr/>
+          <p:nvPr/>
+        </p:nvSpPr>
+        <p:spPr>
+          <a:xfrm>
+            <a:off x="960120" y="4517136"/>
+            <a:ext cx="5394960" cy="384048"/>
+          </a:xfrm>
+          <a:prstGeom prst="rect">
+            <a:avLst/>
+          </a:prstGeom>
+          <a:noFill/>
+          <a:ln/>
+        </p:spPr>
+        <p:txBody>
+          <a:bodyPr wrap="square" lIns="0" tIns="0" rIns="0" bIns="0" rtlCol="0" anchor="ctr"/>
+          <a:lstStyle/>
+          <a:p>
+            <a:pPr indent="0" marL="0">
+              <a:buNone/>
+            </a:pPr>
+            <a:r>
+              <a:rPr lang="en-US" sz="1450" b="1" dirty="0">
+                <a:solidFill>
+                  <a:srgbClr val="0F2142"/>
+                </a:solidFill>
+                <a:latin typeface="Montserrat" pitchFamily="34" charset="0"/>
+                <a:ea typeface="Montserrat" pitchFamily="34" charset="-122"/>
+                <a:cs typeface="Montserrat" pitchFamily="34" charset="-120"/>
+              </a:rPr>
+              <a:t>Huggies and sculptural hoops</a:t>
+            </a:r>
+            <a:pPr indent="0" marL="0">
+              <a:buNone/>
+            </a:pPr>
+            <a:r>
+              <a:rPr lang="en-US" sz="1450" dirty="0">
+                <a:solidFill>
+                  <a:srgbClr val="5B6478"/>
+                </a:solidFill>
+                <a:latin typeface="Montserrat" pitchFamily="34" charset="0"/>
+                <a:ea typeface="Montserrat" pitchFamily="34" charset="-122"/>
+                <a:cs typeface="Montserrat" pitchFamily="34" charset="-120"/>
+              </a:rPr>
+              <a:t>   beating plain hoops</a:t>
+            </a:r>
+            <a:endParaRPr lang="en-US" sz="1450" dirty="0"/>
+          </a:p>
+        </p:txBody>
+      </p:sp>
+      <p:sp>
+        <p:nvSpPr>
+          <p:cNvPr id="17" name="Shape 15"/>
+          <p:cNvSpPr/>
+          <p:nvPr/>
+        </p:nvSpPr>
+        <p:spPr>
+          <a:xfrm>
+            <a:off x="548640" y="5193792"/>
+            <a:ext cx="237744" cy="237744"/>
+          </a:xfrm>
+          <a:prstGeom prst="diamond">
+            <a:avLst/>
+          </a:prstGeom>
+          <a:solidFill>
+            <a:srgbClr val="FFFFFF"/>
+          </a:solidFill>
+          <a:ln w="9525">
+            <a:solidFill>
+              <a:srgbClr val="6F7F99"/>
+            </a:solidFill>
+            <a:prstDash val="solid"/>
+          </a:ln>
+        </p:spPr>
+      </p:sp>
+      <p:sp>
+        <p:nvSpPr>
+          <p:cNvPr id="18" name="Text 16"/>
+          <p:cNvSpPr/>
+          <p:nvPr/>
+        </p:nvSpPr>
+        <p:spPr>
+          <a:xfrm>
+            <a:off x="960120" y="5120640"/>
+            <a:ext cx="5394960" cy="384048"/>
+          </a:xfrm>
+          <a:prstGeom prst="rect">
+            <a:avLst/>
+          </a:prstGeom>
+          <a:noFill/>
+          <a:ln/>
+        </p:spPr>
+        <p:txBody>
+          <a:bodyPr wrap="square" lIns="0" tIns="0" rIns="0" bIns="0" rtlCol="0" anchor="ctr"/>
+          <a:lstStyle/>
+          <a:p>
+            <a:pPr indent="0" marL="0">
+              <a:buNone/>
+            </a:pPr>
+            <a:r>
+              <a:rPr lang="en-US" sz="1450" b="1" dirty="0">
+                <a:solidFill>
+                  <a:srgbClr val="0F2142"/>
+                </a:solidFill>
+                <a:latin typeface="Montserrat" pitchFamily="34" charset="0"/>
+                <a:ea typeface="Montserrat" pitchFamily="34" charset="-122"/>
+                <a:cs typeface="Montserrat" pitchFamily="34" charset="-120"/>
+              </a:rPr>
+              <a:t>Pendants and initials</a:t>
+            </a:r>
+            <a:pPr indent="0" marL="0">
+              <a:buNone/>
+            </a:pPr>
+            <a:r>
+              <a:rPr lang="en-US" sz="1450" dirty="0">
+                <a:solidFill>
+                  <a:srgbClr val="5B6478"/>
+                </a:solidFill>
+                <a:latin typeface="Montserrat" pitchFamily="34" charset="0"/>
+                <a:ea typeface="Montserrat" pitchFamily="34" charset="-122"/>
+                <a:cs typeface="Montserrat" pitchFamily="34" charset="-120"/>
+              </a:rPr>
+              <a:t>   incl. Star of David for Hanukkah</a:t>
+            </a:r>
+            <a:endParaRPr lang="en-US" sz="1450" dirty="0"/>
+          </a:p>
+        </p:txBody>
+      </p:sp>
+      <p:sp>
+        <p:nvSpPr>
+          <p:cNvPr id="19" name="Shape 17"/>
+          <p:cNvSpPr/>
+          <p:nvPr/>
+        </p:nvSpPr>
+        <p:spPr>
+          <a:xfrm>
+            <a:off x="6675120" y="1691640"/>
+            <a:ext cx="4965192" cy="4160520"/>
+          </a:xfrm>
+          <a:prstGeom prst="rect">
+            <a:avLst/>
+          </a:prstGeom>
+          <a:solidFill>
+            <a:srgbClr val="FFFFFF"/>
+          </a:solidFill>
+          <a:ln w="12700">
+            <a:solidFill>
+              <a:srgbClr val="DDD5C3"/>
+            </a:solidFill>
+            <a:prstDash val="solid"/>
+          </a:ln>
+        </p:spPr>
+      </p:sp>
+      <p:sp>
+        <p:nvSpPr>
+          <p:cNvPr id="20" name="Text 18"/>
+          <p:cNvSpPr/>
+          <p:nvPr/>
+        </p:nvSpPr>
+        <p:spPr>
+          <a:xfrm>
+            <a:off x="6995160" y="1828800"/>
+            <a:ext cx="4325112" cy="457200"/>
+          </a:xfrm>
+          <a:prstGeom prst="rect">
+            <a:avLst/>
+          </a:prstGeom>
+          <a:noFill/>
+          <a:ln/>
+        </p:spPr>
+        <p:txBody>
+          <a:bodyPr wrap="square" lIns="0" tIns="0" rIns="0" bIns="0" rtlCol="0" anchor="ctr"/>
+          <a:lstStyle/>
+          <a:p>
+            <a:pPr indent="0" marL="0">
+              <a:buNone/>
+            </a:pPr>
+            <a:r>
+              <a:rPr lang="en-US" sz="2000" dirty="0">
+                <a:solidFill>
+                  <a:srgbClr val="0F2142"/>
+                </a:solidFill>
+                <a:latin typeface="Bodoni Moda" pitchFamily="34" charset="0"/>
+                <a:ea typeface="Bodoni Moda" pitchFamily="34" charset="-122"/>
+                <a:cs typeface="Bodoni Moda" pitchFamily="34" charset="-120"/>
+              </a:rPr>
+              <a:t>Lab vs natural, in plain words</a:t>
+            </a:r>
+            <a:endParaRPr lang="en-US" sz="2000" dirty="0"/>
+          </a:p>
+        </p:txBody>
+      </p:sp>
+      <p:sp>
+        <p:nvSpPr>
+          <p:cNvPr id="21" name="Text 19"/>
+          <p:cNvSpPr/>
+          <p:nvPr/>
+        </p:nvSpPr>
+        <p:spPr>
+          <a:xfrm>
+            <a:off x="6995160" y="2331720"/>
+            <a:ext cx="4325112" cy="274320"/>
+          </a:xfrm>
+          <a:prstGeom prst="rect">
+            <a:avLst/>
+          </a:prstGeom>
+          <a:noFill/>
+          <a:ln/>
+        </p:spPr>
+        <p:txBody>
+          <a:bodyPr wrap="square" lIns="0" tIns="0" rIns="0" bIns="0" rtlCol="0" anchor="ctr"/>
+          <a:lstStyle/>
+          <a:p>
+            <a:pPr indent="0" marL="0">
+              <a:buNone/>
+            </a:pPr>
+            <a:r>
+              <a:rPr lang="en-US" sz="1200" dirty="0">
+                <a:solidFill>
+                  <a:srgbClr val="5B6478"/>
+                </a:solidFill>
+                <a:latin typeface="Montserrat" pitchFamily="34" charset="0"/>
+                <a:ea typeface="Montserrat" pitchFamily="34" charset="-122"/>
+                <a:cs typeface="Montserrat" pitchFamily="34" charset="-120"/>
+              </a:rPr>
+              <a:t>Price of a comparable diamond</a:t>
+            </a:r>
+            <a:endParaRPr lang="en-US" sz="1200" dirty="0"/>
+          </a:p>
+        </p:txBody>
+      </p:sp>
+      <p:sp>
+        <p:nvSpPr>
+          <p:cNvPr id="22" name="Text 20"/>
+          <p:cNvSpPr/>
+          <p:nvPr/>
+        </p:nvSpPr>
+        <p:spPr>
+          <a:xfrm>
+            <a:off x="6995160" y="2697480"/>
+            <a:ext cx="1097280" cy="365760"/>
+          </a:xfrm>
+          <a:prstGeom prst="rect">
+            <a:avLst/>
+          </a:prstGeom>
+          <a:noFill/>
+          <a:ln/>
+        </p:spPr>
+        <p:txBody>
+          <a:bodyPr wrap="square" lIns="0" tIns="0" rIns="0" bIns="0" rtlCol="0" anchor="ctr"/>
+          <a:lstStyle/>
+          <a:p>
+            <a:pPr indent="0" marL="0">
+              <a:buNone/>
+            </a:pPr>
+            <a:r>
+              <a:rPr lang="en-US" sz="1300" b="1" dirty="0">
+                <a:solidFill>
+                  <a:srgbClr val="0F2142"/>
+                </a:solidFill>
+                <a:latin typeface="Montserrat" pitchFamily="34" charset="0"/>
+                <a:ea typeface="Montserrat" pitchFamily="34" charset="-122"/>
+                <a:cs typeface="Montserrat" pitchFamily="34" charset="-120"/>
+              </a:rPr>
+              <a:t>Lab-grown</a:t>
+            </a:r>
+            <a:endParaRPr lang="en-US" sz="1300" dirty="0"/>
+          </a:p>
+        </p:txBody>
+      </p:sp>
+      <p:sp>
+        <p:nvSpPr>
+          <p:cNvPr id="23" name="Shape 21"/>
+          <p:cNvSpPr/>
+          <p:nvPr/>
+        </p:nvSpPr>
+        <p:spPr>
+          <a:xfrm>
+            <a:off x="8092440" y="2743200"/>
+            <a:ext cx="437198" cy="274320"/>
+          </a:xfrm>
+          <a:prstGeom prst="rect">
             <a:avLst/>
           </a:prstGeom>
           <a:solidFill>
@@ -13382,598 +14052,6 @@
       </p:sp>
       <p:sp>
         <p:nvSpPr>
-          <p:cNvPr id="8" name="Text 6"/>
-          <p:cNvSpPr/>
-          <p:nvPr/>
-        </p:nvSpPr>
-        <p:spPr>
-          <a:xfrm>
-            <a:off x="960120" y="2103120"/>
-            <a:ext cx="5394960" cy="384048"/>
-          </a:xfrm>
-          <a:prstGeom prst="rect">
-            <a:avLst/>
-          </a:prstGeom>
-          <a:noFill/>
-          <a:ln/>
-        </p:spPr>
-        <p:txBody>
-          <a:bodyPr wrap="square" lIns="0" tIns="0" rIns="0" bIns="0" rtlCol="0" anchor="ctr"/>
-          <a:lstStyle/>
-          <a:p>
-            <a:pPr indent="0" marL="0">
-              <a:buNone/>
-            </a:pPr>
-            <a:r>
-              <a:rPr lang="en-US" sz="1450" b="1" dirty="0">
-                <a:solidFill>
-                  <a:srgbClr val="0F2142"/>
-                </a:solidFill>
-                <a:latin typeface="Montserrat" pitchFamily="34" charset="0"/>
-                <a:ea typeface="Montserrat" pitchFamily="34" charset="-122"/>
-                <a:cs typeface="Montserrat" pitchFamily="34" charset="-120"/>
-              </a:rPr>
-              <a:t>Tennis bracelets</a:t>
-            </a:r>
-            <a:r>
-              <a:rPr lang="en-US" sz="1450" dirty="0">
-                <a:solidFill>
-                  <a:srgbClr val="5B6478"/>
-                </a:solidFill>
-                <a:latin typeface="Montserrat" pitchFamily="34" charset="0"/>
-                <a:ea typeface="Montserrat" pitchFamily="34" charset="-122"/>
-                <a:cs typeface="Montserrat" pitchFamily="34" charset="-120"/>
-              </a:rPr>
-              <a:t>   the #1 holiday gift</a:t>
-            </a:r>
-            <a:endParaRPr lang="en-US" sz="1450" dirty="0"/>
-          </a:p>
-        </p:txBody>
-      </p:sp>
-      <p:sp>
-        <p:nvSpPr>
-          <p:cNvPr id="9" name="Shape 7"/>
-          <p:cNvSpPr/>
-          <p:nvPr/>
-        </p:nvSpPr>
-        <p:spPr>
-          <a:xfrm>
-            <a:off x="548640" y="2779776"/>
-            <a:ext cx="237744" cy="237744"/>
-          </a:xfrm>
-          <a:prstGeom prst="diamond">
-            <a:avLst/>
-          </a:prstGeom>
-          <a:solidFill>
-            <a:srgbClr val="C6A15B"/>
-          </a:solidFill>
-          <a:ln w="12700">
-            <a:solidFill>
-              <a:srgbClr val="C6A15B"/>
-            </a:solidFill>
-            <a:prstDash val="solid"/>
-          </a:ln>
-        </p:spPr>
-      </p:sp>
-      <p:sp>
-        <p:nvSpPr>
-          <p:cNvPr id="10" name="Text 8"/>
-          <p:cNvSpPr/>
-          <p:nvPr/>
-        </p:nvSpPr>
-        <p:spPr>
-          <a:xfrm>
-            <a:off x="960120" y="2706624"/>
-            <a:ext cx="5394960" cy="384048"/>
-          </a:xfrm>
-          <a:prstGeom prst="rect">
-            <a:avLst/>
-          </a:prstGeom>
-          <a:noFill/>
-          <a:ln/>
-        </p:spPr>
-        <p:txBody>
-          <a:bodyPr wrap="square" lIns="0" tIns="0" rIns="0" bIns="0" rtlCol="0" anchor="ctr"/>
-          <a:lstStyle/>
-          <a:p>
-            <a:pPr indent="0" marL="0">
-              <a:buNone/>
-            </a:pPr>
-            <a:r>
-              <a:rPr lang="en-US" sz="1450" b="1" dirty="0">
-                <a:solidFill>
-                  <a:srgbClr val="0F2142"/>
-                </a:solidFill>
-                <a:latin typeface="Montserrat" pitchFamily="34" charset="0"/>
-                <a:ea typeface="Montserrat" pitchFamily="34" charset="-122"/>
-                <a:cs typeface="Montserrat" pitchFamily="34" charset="-120"/>
-              </a:rPr>
-              <a:t>Diamond studs</a:t>
-            </a:r>
-            <a:r>
-              <a:rPr lang="en-US" sz="1450" dirty="0">
-                <a:solidFill>
-                  <a:srgbClr val="5B6478"/>
-                </a:solidFill>
-                <a:latin typeface="Montserrat" pitchFamily="34" charset="0"/>
-                <a:ea typeface="Montserrat" pitchFamily="34" charset="-122"/>
-                <a:cs typeface="Montserrat" pitchFamily="34" charset="-120"/>
-              </a:rPr>
-              <a:t>   the classic first fine-jewelry gift</a:t>
-            </a:r>
-            <a:endParaRPr lang="en-US" sz="1450" dirty="0"/>
-          </a:p>
-        </p:txBody>
-      </p:sp>
-      <p:sp>
-        <p:nvSpPr>
-          <p:cNvPr id="11" name="Shape 9"/>
-          <p:cNvSpPr/>
-          <p:nvPr/>
-        </p:nvSpPr>
-        <p:spPr>
-          <a:xfrm>
-            <a:off x="548640" y="3383280"/>
-            <a:ext cx="237744" cy="237744"/>
-          </a:xfrm>
-          <a:prstGeom prst="diamond">
-            <a:avLst/>
-          </a:prstGeom>
-          <a:solidFill>
-            <a:srgbClr val="C6A15B"/>
-          </a:solidFill>
-          <a:ln w="12700">
-            <a:solidFill>
-              <a:srgbClr val="C6A15B"/>
-            </a:solidFill>
-            <a:prstDash val="solid"/>
-          </a:ln>
-        </p:spPr>
-      </p:sp>
-      <p:sp>
-        <p:nvSpPr>
-          <p:cNvPr id="12" name="Text 10"/>
-          <p:cNvSpPr/>
-          <p:nvPr/>
-        </p:nvSpPr>
-        <p:spPr>
-          <a:xfrm>
-            <a:off x="960120" y="3310128"/>
-            <a:ext cx="5394960" cy="384048"/>
-          </a:xfrm>
-          <a:prstGeom prst="rect">
-            <a:avLst/>
-          </a:prstGeom>
-          <a:noFill/>
-          <a:ln/>
-        </p:spPr>
-        <p:txBody>
-          <a:bodyPr wrap="square" lIns="0" tIns="0" rIns="0" bIns="0" rtlCol="0" anchor="ctr"/>
-          <a:lstStyle/>
-          <a:p>
-            <a:pPr indent="0" marL="0">
-              <a:buNone/>
-            </a:pPr>
-            <a:r>
-              <a:rPr lang="en-US" sz="1450" b="1" dirty="0">
-                <a:solidFill>
-                  <a:srgbClr val="0F2142"/>
-                </a:solidFill>
-                <a:latin typeface="Montserrat" pitchFamily="34" charset="0"/>
-                <a:ea typeface="Montserrat" pitchFamily="34" charset="-122"/>
-                <a:cs typeface="Montserrat" pitchFamily="34" charset="-120"/>
-              </a:rPr>
-              <a:t>Tennis necklaces</a:t>
-            </a:r>
-            <a:r>
-              <a:rPr lang="en-US" sz="1450" dirty="0">
-                <a:solidFill>
-                  <a:srgbClr val="5B6478"/>
-                </a:solidFill>
-                <a:latin typeface="Montserrat" pitchFamily="34" charset="0"/>
-                <a:ea typeface="Montserrat" pitchFamily="34" charset="-122"/>
-                <a:cs typeface="Montserrat" pitchFamily="34" charset="-120"/>
-              </a:rPr>
-              <a:t>   right behind bracelets</a:t>
-            </a:r>
-            <a:endParaRPr lang="en-US" sz="1450" dirty="0"/>
-          </a:p>
-        </p:txBody>
-      </p:sp>
-      <p:sp>
-        <p:nvSpPr>
-          <p:cNvPr id="13" name="Shape 11"/>
-          <p:cNvSpPr/>
-          <p:nvPr/>
-        </p:nvSpPr>
-        <p:spPr>
-          <a:xfrm>
-            <a:off x="548640" y="3986784"/>
-            <a:ext cx="237744" cy="237744"/>
-          </a:xfrm>
-          <a:prstGeom prst="diamond">
-            <a:avLst/>
-          </a:prstGeom>
-          <a:solidFill>
-            <a:srgbClr val="C6A15B"/>
-          </a:solidFill>
-          <a:ln w="12700">
-            <a:solidFill>
-              <a:srgbClr val="C6A15B"/>
-            </a:solidFill>
-            <a:prstDash val="solid"/>
-          </a:ln>
-        </p:spPr>
-      </p:sp>
-      <p:sp>
-        <p:nvSpPr>
-          <p:cNvPr id="14" name="Text 12"/>
-          <p:cNvSpPr/>
-          <p:nvPr/>
-        </p:nvSpPr>
-        <p:spPr>
-          <a:xfrm>
-            <a:off x="960120" y="3913632"/>
-            <a:ext cx="5394960" cy="384048"/>
-          </a:xfrm>
-          <a:prstGeom prst="rect">
-            <a:avLst/>
-          </a:prstGeom>
-          <a:noFill/>
-          <a:ln/>
-        </p:spPr>
-        <p:txBody>
-          <a:bodyPr wrap="square" lIns="0" tIns="0" rIns="0" bIns="0" rtlCol="0" anchor="ctr"/>
-          <a:lstStyle/>
-          <a:p>
-            <a:pPr indent="0" marL="0">
-              <a:buNone/>
-            </a:pPr>
-            <a:r>
-              <a:rPr lang="en-US" sz="1450" b="1" dirty="0">
-                <a:solidFill>
-                  <a:srgbClr val="0F2142"/>
-                </a:solidFill>
-                <a:latin typeface="Montserrat" pitchFamily="34" charset="0"/>
-                <a:ea typeface="Montserrat" pitchFamily="34" charset="-122"/>
-                <a:cs typeface="Montserrat" pitchFamily="34" charset="-120"/>
-              </a:rPr>
-              <a:t>Gold chains</a:t>
-            </a:r>
-            <a:r>
-              <a:rPr lang="en-US" sz="1450" dirty="0">
-                <a:solidFill>
-                  <a:srgbClr val="5B6478"/>
-                </a:solidFill>
-                <a:latin typeface="Montserrat" pitchFamily="34" charset="0"/>
-                <a:ea typeface="Montserrat" pitchFamily="34" charset="-122"/>
-                <a:cs typeface="Montserrat" pitchFamily="34" charset="-120"/>
-              </a:rPr>
-              <a:t>   Cuban (the Vegas favorite), rope, paperclip</a:t>
-            </a:r>
-            <a:endParaRPr lang="en-US" sz="1450" dirty="0"/>
-          </a:p>
-        </p:txBody>
-      </p:sp>
-      <p:sp>
-        <p:nvSpPr>
-          <p:cNvPr id="15" name="Shape 13"/>
-          <p:cNvSpPr/>
-          <p:nvPr/>
-        </p:nvSpPr>
-        <p:spPr>
-          <a:xfrm>
-            <a:off x="548640" y="4590288"/>
-            <a:ext cx="237744" cy="237744"/>
-          </a:xfrm>
-          <a:prstGeom prst="diamond">
-            <a:avLst/>
-          </a:prstGeom>
-          <a:solidFill>
-            <a:srgbClr val="C6A15B"/>
-          </a:solidFill>
-          <a:ln w="12700">
-            <a:solidFill>
-              <a:srgbClr val="C6A15B"/>
-            </a:solidFill>
-            <a:prstDash val="solid"/>
-          </a:ln>
-        </p:spPr>
-      </p:sp>
-      <p:sp>
-        <p:nvSpPr>
-          <p:cNvPr id="16" name="Text 14"/>
-          <p:cNvSpPr/>
-          <p:nvPr/>
-        </p:nvSpPr>
-        <p:spPr>
-          <a:xfrm>
-            <a:off x="960120" y="4517136"/>
-            <a:ext cx="5394960" cy="384048"/>
-          </a:xfrm>
-          <a:prstGeom prst="rect">
-            <a:avLst/>
-          </a:prstGeom>
-          <a:noFill/>
-          <a:ln/>
-        </p:spPr>
-        <p:txBody>
-          <a:bodyPr wrap="square" lIns="0" tIns="0" rIns="0" bIns="0" rtlCol="0" anchor="ctr"/>
-          <a:lstStyle/>
-          <a:p>
-            <a:pPr indent="0" marL="0">
-              <a:buNone/>
-            </a:pPr>
-            <a:r>
-              <a:rPr lang="en-US" sz="1450" b="1" dirty="0">
-                <a:solidFill>
-                  <a:srgbClr val="0F2142"/>
-                </a:solidFill>
-                <a:latin typeface="Montserrat" pitchFamily="34" charset="0"/>
-                <a:ea typeface="Montserrat" pitchFamily="34" charset="-122"/>
-                <a:cs typeface="Montserrat" pitchFamily="34" charset="-120"/>
-              </a:rPr>
-              <a:t>Huggies and sculptural hoops</a:t>
-            </a:r>
-            <a:r>
-              <a:rPr lang="en-US" sz="1450" dirty="0">
-                <a:solidFill>
-                  <a:srgbClr val="5B6478"/>
-                </a:solidFill>
-                <a:latin typeface="Montserrat" pitchFamily="34" charset="0"/>
-                <a:ea typeface="Montserrat" pitchFamily="34" charset="-122"/>
-                <a:cs typeface="Montserrat" pitchFamily="34" charset="-120"/>
-              </a:rPr>
-              <a:t>   beating plain hoops</a:t>
-            </a:r>
-            <a:endParaRPr lang="en-US" sz="1450" dirty="0"/>
-          </a:p>
-        </p:txBody>
-      </p:sp>
-      <p:sp>
-        <p:nvSpPr>
-          <p:cNvPr id="17" name="Shape 15"/>
-          <p:cNvSpPr/>
-          <p:nvPr/>
-        </p:nvSpPr>
-        <p:spPr>
-          <a:xfrm>
-            <a:off x="548640" y="5193792"/>
-            <a:ext cx="237744" cy="237744"/>
-          </a:xfrm>
-          <a:prstGeom prst="diamond">
-            <a:avLst/>
-          </a:prstGeom>
-          <a:solidFill>
-            <a:srgbClr val="C6A15B"/>
-          </a:solidFill>
-          <a:ln w="12700">
-            <a:solidFill>
-              <a:srgbClr val="C6A15B"/>
-            </a:solidFill>
-            <a:prstDash val="solid"/>
-          </a:ln>
-        </p:spPr>
-      </p:sp>
-      <p:sp>
-        <p:nvSpPr>
-          <p:cNvPr id="18" name="Text 16"/>
-          <p:cNvSpPr/>
-          <p:nvPr/>
-        </p:nvSpPr>
-        <p:spPr>
-          <a:xfrm>
-            <a:off x="960120" y="5120640"/>
-            <a:ext cx="5394960" cy="384048"/>
-          </a:xfrm>
-          <a:prstGeom prst="rect">
-            <a:avLst/>
-          </a:prstGeom>
-          <a:noFill/>
-          <a:ln/>
-        </p:spPr>
-        <p:txBody>
-          <a:bodyPr wrap="square" lIns="0" tIns="0" rIns="0" bIns="0" rtlCol="0" anchor="ctr"/>
-          <a:lstStyle/>
-          <a:p>
-            <a:pPr indent="0" marL="0">
-              <a:buNone/>
-            </a:pPr>
-            <a:r>
-              <a:rPr lang="en-US" sz="1450" b="1" dirty="0">
-                <a:solidFill>
-                  <a:srgbClr val="0F2142"/>
-                </a:solidFill>
-                <a:latin typeface="Montserrat" pitchFamily="34" charset="0"/>
-                <a:ea typeface="Montserrat" pitchFamily="34" charset="-122"/>
-                <a:cs typeface="Montserrat" pitchFamily="34" charset="-120"/>
-              </a:rPr>
-              <a:t>Pendants and initials</a:t>
-            </a:r>
-            <a:r>
-              <a:rPr lang="en-US" sz="1450" dirty="0">
-                <a:solidFill>
-                  <a:srgbClr val="5B6478"/>
-                </a:solidFill>
-                <a:latin typeface="Montserrat" pitchFamily="34" charset="0"/>
-                <a:ea typeface="Montserrat" pitchFamily="34" charset="-122"/>
-                <a:cs typeface="Montserrat" pitchFamily="34" charset="-120"/>
-              </a:rPr>
-              <a:t>   incl. Star of David for Hanukkah</a:t>
-            </a:r>
-            <a:endParaRPr lang="en-US" sz="1450" dirty="0"/>
-          </a:p>
-        </p:txBody>
-      </p:sp>
-      <p:sp>
-        <p:nvSpPr>
-          <p:cNvPr id="19" name="Shape 17"/>
-          <p:cNvSpPr/>
-          <p:nvPr/>
-        </p:nvSpPr>
-        <p:spPr>
-          <a:xfrm>
-            <a:off x="6675120" y="1691640"/>
-            <a:ext cx="4965192" cy="4160520"/>
-          </a:xfrm>
-          <a:prstGeom prst="rect">
-            <a:avLst/>
-          </a:prstGeom>
-          <a:solidFill>
-            <a:srgbClr val="FFFFFF"/>
-          </a:solidFill>
-          <a:ln w="12700">
-            <a:solidFill>
-              <a:srgbClr val="DDD5C3"/>
-            </a:solidFill>
-            <a:prstDash val="solid"/>
-          </a:ln>
-        </p:spPr>
-      </p:sp>
-      <p:sp>
-        <p:nvSpPr>
-          <p:cNvPr id="20" name="Text 18"/>
-          <p:cNvSpPr/>
-          <p:nvPr/>
-        </p:nvSpPr>
-        <p:spPr>
-          <a:xfrm>
-            <a:off x="6995160" y="1828800"/>
-            <a:ext cx="4325112" cy="457200"/>
-          </a:xfrm>
-          <a:prstGeom prst="rect">
-            <a:avLst/>
-          </a:prstGeom>
-          <a:noFill/>
-          <a:ln/>
-        </p:spPr>
-        <p:txBody>
-          <a:bodyPr wrap="square" lIns="0" tIns="0" rIns="0" bIns="0" rtlCol="0" anchor="ctr"/>
-          <a:lstStyle/>
-          <a:p>
-            <a:pPr indent="0" marL="0">
-              <a:buNone/>
-            </a:pPr>
-            <a:r>
-              <a:rPr lang="en-US" sz="2000" dirty="0">
-                <a:solidFill>
-                  <a:srgbClr val="0F2142"/>
-                </a:solidFill>
-                <a:latin typeface="Bodoni Moda" pitchFamily="34" charset="0"/>
-                <a:ea typeface="Bodoni Moda" pitchFamily="34" charset="-122"/>
-                <a:cs typeface="Bodoni Moda" pitchFamily="34" charset="-120"/>
-              </a:rPr>
-              <a:t>Lab vs natural, in plain words</a:t>
-            </a:r>
-            <a:endParaRPr lang="en-US" sz="2000" dirty="0"/>
-          </a:p>
-        </p:txBody>
-      </p:sp>
-      <p:sp>
-        <p:nvSpPr>
-          <p:cNvPr id="21" name="Text 19"/>
-          <p:cNvSpPr/>
-          <p:nvPr/>
-        </p:nvSpPr>
-        <p:spPr>
-          <a:xfrm>
-            <a:off x="6995160" y="2331720"/>
-            <a:ext cx="4325112" cy="274320"/>
-          </a:xfrm>
-          <a:prstGeom prst="rect">
-            <a:avLst/>
-          </a:prstGeom>
-          <a:noFill/>
-          <a:ln/>
-        </p:spPr>
-        <p:txBody>
-          <a:bodyPr wrap="square" lIns="0" tIns="0" rIns="0" bIns="0" rtlCol="0" anchor="ctr"/>
-          <a:lstStyle/>
-          <a:p>
-            <a:pPr indent="0" marL="0">
-              <a:buNone/>
-            </a:pPr>
-            <a:r>
-              <a:rPr lang="en-US" sz="1200" dirty="0">
-                <a:solidFill>
-                  <a:srgbClr val="5B6478"/>
-                </a:solidFill>
-                <a:latin typeface="Montserrat" pitchFamily="34" charset="0"/>
-                <a:ea typeface="Montserrat" pitchFamily="34" charset="-122"/>
-                <a:cs typeface="Montserrat" pitchFamily="34" charset="-120"/>
-              </a:rPr>
-              <a:t>Price of a comparable diamond</a:t>
-            </a:r>
-            <a:endParaRPr lang="en-US" sz="1200" dirty="0"/>
-          </a:p>
-        </p:txBody>
-      </p:sp>
-      <p:sp>
-        <p:nvSpPr>
-          <p:cNvPr id="22" name="Text 20"/>
-          <p:cNvSpPr/>
-          <p:nvPr/>
-        </p:nvSpPr>
-        <p:spPr>
-          <a:xfrm>
-            <a:off x="6995160" y="2697480"/>
-            <a:ext cx="1097280" cy="365760"/>
-          </a:xfrm>
-          <a:prstGeom prst="rect">
-            <a:avLst/>
-          </a:prstGeom>
-          <a:noFill/>
-          <a:ln/>
-        </p:spPr>
-        <p:txBody>
-          <a:bodyPr wrap="square" lIns="0" tIns="0" rIns="0" bIns="0" rtlCol="0" anchor="ctr"/>
-          <a:lstStyle/>
-          <a:p>
-            <a:pPr indent="0" marL="0">
-              <a:buNone/>
-            </a:pPr>
-            <a:r>
-              <a:rPr lang="en-US" sz="1300" b="1" dirty="0">
-                <a:solidFill>
-                  <a:srgbClr val="0F2142"/>
-                </a:solidFill>
-                <a:latin typeface="Montserrat" pitchFamily="34" charset="0"/>
-                <a:ea typeface="Montserrat" pitchFamily="34" charset="-122"/>
-                <a:cs typeface="Montserrat" pitchFamily="34" charset="-120"/>
-              </a:rPr>
-              <a:t>Lab-grown</a:t>
-            </a:r>
-            <a:endParaRPr lang="en-US" sz="1300" dirty="0"/>
-          </a:p>
-        </p:txBody>
-      </p:sp>
-      <p:sp>
-        <p:nvSpPr>
-          <p:cNvPr id="23" name="Shape 21"/>
-          <p:cNvSpPr/>
-          <p:nvPr/>
-        </p:nvSpPr>
-        <p:spPr>
-          <a:xfrm>
-            <a:off x="8092440" y="2743200"/>
-            <a:ext cx="437198" cy="274320"/>
-          </a:xfrm>
-          <a:prstGeom prst="rect">
-            <a:avLst/>
-          </a:prstGeom>
-          <a:solidFill>
-            <a:srgbClr val="C6A15B"/>
-          </a:solidFill>
-          <a:ln w="12700">
-            <a:solidFill>
-              <a:srgbClr val="C6A15B"/>
-            </a:solidFill>
-            <a:prstDash val="solid"/>
-          </a:ln>
-        </p:spPr>
-      </p:sp>
-      <p:sp>
-        <p:nvSpPr>
           <p:cNvPr id="24" name="Text 22"/>
           <p:cNvSpPr/>
           <p:nvPr/>
@@ -14175,20 +14253,6 @@
               </a:rPr>
               <a:t>Lab-grown: </a:t>
             </a:r>
-            <a:r>
-              <a:rPr lang="en-US" sz="1250" dirty="0">
-                <a:solidFill>
-                  <a:srgbClr val="5B6478"/>
-                </a:solidFill>
-                <a:latin typeface="Montserrat" pitchFamily="34" charset="0"/>
-                <a:ea typeface="Montserrat" pitchFamily="34" charset="-122"/>
-                <a:cs typeface="Montserrat" pitchFamily="34" charset="-120"/>
-              </a:rPr>
-              <a:t>much more size for the money. 61% of 2025 engagement rings used one.</a:t>
-            </a:r>
-            <a:endParaRPr lang="en-US" sz="1250" dirty="0"/>
-          </a:p>
-          <a:p>
             <a:pPr indent="0" marL="0">
               <a:spcAft>
                 <a:spcPts val="600"/>
@@ -14196,17 +14260,6 @@
               <a:buNone/>
             </a:pPr>
             <a:r>
-              <a:rPr lang="en-US" sz="1250" b="1" dirty="0">
-                <a:solidFill>
-                  <a:srgbClr val="0F2142"/>
-                </a:solidFill>
-                <a:latin typeface="Montserrat" pitchFamily="34" charset="0"/>
-                <a:ea typeface="Montserrat" pitchFamily="34" charset="-122"/>
-                <a:cs typeface="Montserrat" pitchFamily="34" charset="-120"/>
-              </a:rPr>
-              <a:t>Natural: </a:t>
-            </a:r>
-            <a:r>
               <a:rPr lang="en-US" sz="1250" dirty="0">
                 <a:solidFill>
                   <a:srgbClr val="5B6478"/>
@@ -14215,7 +14268,7 @@
                 <a:ea typeface="Montserrat" pitchFamily="34" charset="-122"/>
                 <a:cs typeface="Montserrat" pitchFamily="34" charset="-120"/>
               </a:rPr>
-              <a:t>mined. A 1 ct stone averages $3,898, down 51% since 2021.</a:t>
+              <a:t>much more size for the money. 61% of 2025 engagement rings used one.</a:t>
             </a:r>
             <a:endParaRPr lang="en-US" sz="1250" dirty="0"/>
           </a:p>
@@ -14229,6 +14282,43 @@
             <a:r>
               <a:rPr lang="en-US" sz="1250" b="1" dirty="0">
                 <a:solidFill>
+                  <a:srgbClr val="0F2142"/>
+                </a:solidFill>
+                <a:latin typeface="Montserrat" pitchFamily="34" charset="0"/>
+                <a:ea typeface="Montserrat" pitchFamily="34" charset="-122"/>
+                <a:cs typeface="Montserrat" pitchFamily="34" charset="-120"/>
+              </a:rPr>
+              <a:t>Natural: </a:t>
+            </a:r>
+            <a:pPr indent="0" marL="0">
+              <a:spcAft>
+                <a:spcPts val="600"/>
+              </a:spcAft>
+              <a:buNone/>
+            </a:pPr>
+            <a:r>
+              <a:rPr lang="en-US" sz="1250" dirty="0">
+                <a:solidFill>
+                  <a:srgbClr val="5B6478"/>
+                </a:solidFill>
+                <a:latin typeface="Montserrat" pitchFamily="34" charset="0"/>
+                <a:ea typeface="Montserrat" pitchFamily="34" charset="-122"/>
+                <a:cs typeface="Montserrat" pitchFamily="34" charset="-120"/>
+              </a:rPr>
+              <a:t>mined. A 1 ct stone averages $3,898, down 51% since 2021.</a:t>
+            </a:r>
+            <a:endParaRPr lang="en-US" sz="1250" dirty="0"/>
+          </a:p>
+          <a:p>
+            <a:pPr indent="0" marL="0">
+              <a:spcAft>
+                <a:spcPts val="600"/>
+              </a:spcAft>
+              <a:buNone/>
+            </a:pPr>
+            <a:r>
+              <a:rPr lang="en-US" sz="1250" b="1" dirty="0">
+                <a:solidFill>
                   <a:srgbClr val="C6A15B"/>
                 </a:solidFill>
                 <a:latin typeface="Montserrat" pitchFamily="34" charset="0"/>
@@ -14237,6 +14327,12 @@
               </a:rPr>
               <a:t>Recommendation: </a:t>
             </a:r>
+            <a:pPr indent="0" marL="0">
+              <a:spcAft>
+                <a:spcPts val="600"/>
+              </a:spcAft>
+              <a:buNone/>
+            </a:pPr>
             <a:r>
               <a:rPr lang="en-US" sz="1250" dirty="0">
                 <a:solidFill>
@@ -14358,6 +14454,9 @@
               </a:rPr>
               <a:t>Zisel</a:t>
             </a:r>
+            <a:pPr indent="0" marL="0">
+              <a:buNone/>
+            </a:pPr>
             <a:r>
               <a:rPr lang="en-US" sz="1000" dirty="0">
                 <a:solidFill>
@@ -15325,6 +15424,9 @@
               </a:rPr>
               <a:t>Holiday Sip &amp; Shop idea: </a:t>
             </a:r>
+            <a:pPr indent="0" marL="0">
+              <a:buNone/>
+            </a:pPr>
             <a:r>
               <a:rPr lang="en-US" sz="1250" dirty="0">
                 <a:solidFill>
@@ -15446,6 +15548,9 @@
               </a:rPr>
               <a:t>Zisel</a:t>
             </a:r>
+            <a:pPr indent="0" marL="0">
+              <a:buNone/>
+            </a:pPr>
             <a:r>
               <a:rPr lang="en-US" sz="1000" dirty="0">
                 <a:solidFill>
@@ -15713,11 +15818,11 @@
             <a:avLst/>
           </a:prstGeom>
           <a:solidFill>
-            <a:srgbClr val="C6A15B"/>
+            <a:srgbClr val="FFFFFF"/>
           </a:solidFill>
-          <a:ln w="12700">
+          <a:ln w="9525">
             <a:solidFill>
-              <a:srgbClr val="C6A15B"/>
+              <a:srgbClr val="6F7F99"/>
             </a:solidFill>
             <a:prstDash val="solid"/>
           </a:ln>
@@ -15777,11 +15882,11 @@
             <a:avLst/>
           </a:prstGeom>
           <a:solidFill>
-            <a:srgbClr val="C6A15B"/>
+            <a:srgbClr val="FFFFFF"/>
           </a:solidFill>
-          <a:ln w="12700">
+          <a:ln w="9525">
             <a:solidFill>
-              <a:srgbClr val="C6A15B"/>
+              <a:srgbClr val="6F7F99"/>
             </a:solidFill>
             <a:prstDash val="solid"/>
           </a:ln>
@@ -15841,11 +15946,11 @@
             <a:avLst/>
           </a:prstGeom>
           <a:solidFill>
-            <a:srgbClr val="C6A15B"/>
+            <a:srgbClr val="FFFFFF"/>
           </a:solidFill>
-          <a:ln w="12700">
+          <a:ln w="9525">
             <a:solidFill>
-              <a:srgbClr val="C6A15B"/>
+              <a:srgbClr val="6F7F99"/>
             </a:solidFill>
             <a:prstDash val="solid"/>
           </a:ln>
@@ -15905,11 +16010,11 @@
             <a:avLst/>
           </a:prstGeom>
           <a:solidFill>
-            <a:srgbClr val="C6A15B"/>
+            <a:srgbClr val="FFFFFF"/>
           </a:solidFill>
-          <a:ln w="12700">
+          <a:ln w="9525">
             <a:solidFill>
-              <a:srgbClr val="C6A15B"/>
+              <a:srgbClr val="6F7F99"/>
             </a:solidFill>
             <a:prstDash val="solid"/>
           </a:ln>
@@ -15969,11 +16074,11 @@
             <a:avLst/>
           </a:prstGeom>
           <a:solidFill>
-            <a:srgbClr val="C6A15B"/>
+            <a:srgbClr val="FFFFFF"/>
           </a:solidFill>
-          <a:ln w="12700">
+          <a:ln w="9525">
             <a:solidFill>
-              <a:srgbClr val="C6A15B"/>
+              <a:srgbClr val="6F7F99"/>
             </a:solidFill>
             <a:prstDash val="solid"/>
           </a:ln>
@@ -16033,11 +16138,11 @@
             <a:avLst/>
           </a:prstGeom>
           <a:solidFill>
-            <a:srgbClr val="C6A15B"/>
+            <a:srgbClr val="FFFFFF"/>
           </a:solidFill>
-          <a:ln w="12700">
+          <a:ln w="9525">
             <a:solidFill>
-              <a:srgbClr val="C6A15B"/>
+              <a:srgbClr val="6F7F99"/>
             </a:solidFill>
             <a:prstDash val="solid"/>
           </a:ln>
@@ -16136,11 +16241,11 @@
             <a:avLst/>
           </a:prstGeom>
           <a:solidFill>
-            <a:srgbClr val="C6A15B"/>
+            <a:srgbClr val="FFFFFF"/>
           </a:solidFill>
-          <a:ln w="12700">
+          <a:ln w="9525">
             <a:solidFill>
-              <a:srgbClr val="C6A15B"/>
+              <a:srgbClr val="6F7F99"/>
             </a:solidFill>
             <a:prstDash val="solid"/>
           </a:ln>
@@ -16200,11 +16305,11 @@
             <a:avLst/>
           </a:prstGeom>
           <a:solidFill>
-            <a:srgbClr val="C6A15B"/>
+            <a:srgbClr val="FFFFFF"/>
           </a:solidFill>
-          <a:ln w="12700">
+          <a:ln w="9525">
             <a:solidFill>
-              <a:srgbClr val="C6A15B"/>
+              <a:srgbClr val="6F7F99"/>
             </a:solidFill>
             <a:prstDash val="solid"/>
           </a:ln>
@@ -16264,11 +16369,11 @@
             <a:avLst/>
           </a:prstGeom>
           <a:solidFill>
-            <a:srgbClr val="C6A15B"/>
+            <a:srgbClr val="FFFFFF"/>
           </a:solidFill>
-          <a:ln w="12700">
+          <a:ln w="9525">
             <a:solidFill>
-              <a:srgbClr val="C6A15B"/>
+              <a:srgbClr val="6F7F99"/>
             </a:solidFill>
             <a:prstDash val="solid"/>
           </a:ln>

</xml_diff>